<commit_message>
Source pptx: slide 2's duplicate salmon eyebrow removed
</commit_message>
<xml_diff>
--- a/harry-potter-present-continuous.pptx
+++ b/harry-potter-present-continuous.pptx
@@ -3277,71 +3277,6 @@
       </p:sp>
       <p:sp>
         <p:nvSpPr>
-          <p:cNvPr id="5" name="Grammar 2">
-            <a:extLst xmlns:a="http://schemas.openxmlformats.org/drawingml/2006/main">
-              <a:ext uri="{FF2B5EF4-FFF2-40B4-BE49-F238E27FC236}">
-                <a16:creationId xmlns:a16="http://schemas.microsoft.com/office/drawing/2014/main" id="{69C85DF3-7CF4-437E-91A1-217E2B941F68}"/>
-              </a:ext>
-            </a:extLst>
-          </p:cNvPr>
-          <p:cNvSpPr>
-            <a:spLocks xmlns:a="http://schemas.openxmlformats.org/drawingml/2006/main" noGrp="1"/>
-          </p:cNvSpPr>
-          <p:nvPr/>
-        </p:nvSpPr>
-        <p:spPr>
-          <a:xfrm xmlns:a="http://schemas.openxmlformats.org/drawingml/2006/main">
-            <a:off x="407035" y="44450"/>
-            <a:ext cx="3143250" cy="266700"/>
-          </a:xfrm>
-          <a:prstGeom xmlns:a="http://schemas.openxmlformats.org/drawingml/2006/main" prst="rect">
-            <a:avLst/>
-          </a:prstGeom>
-          <a:noFill xmlns:a="http://schemas.openxmlformats.org/drawingml/2006/main"/>
-          <a:ln xmlns:a="http://schemas.openxmlformats.org/drawingml/2006/main" w="0">
-            <a:noFill/>
-            <a:prstDash val="solid"/>
-          </a:ln>
-        </p:spPr>
-        <p:txBody>
-          <a:bodyPr xmlns:a="http://schemas.openxmlformats.org/drawingml/2006/main" lIns="0" tIns="0" rIns="0" bIns="0" anchor="ctr"/>
-          <a:lstStyle xmlns:a="http://schemas.openxmlformats.org/drawingml/2006/main"/>
-          <a:p xmlns:a="http://schemas.openxmlformats.org/drawingml/2006/main">
-            <a:pPr algn="l">
-              <a:buNone/>
-              <a:defRPr sz="1350" b="1">
-                <a:solidFill>
-                  <a:srgbClr val="E85F5B"/>
-                </a:solidFill>
-                <a:latin typeface="Courier New"/>
-                <a:ea typeface="Courier New"/>
-                <a:cs typeface="Courier New"/>
-              </a:defRPr>
-            </a:pPr>
-            <a:r>
-              <a:rPr sz="1350" b="1">
-                <a:solidFill>
-                  <a:srgbClr val="E85F5B"/>
-                </a:solidFill>
-                <a:latin typeface="Courier New"/>
-                <a:ea typeface="Courier New"/>
-                <a:cs typeface="Courier New"/>
-              </a:rPr>
-              <a:t>TALK → IS TALKING</a:t>
-            </a:r>
-            <a:endParaRPr sz="1350" b="1">
-              <a:solidFill>
-                <a:srgbClr val="E85F5B"/>
-              </a:solidFill>
-              <a:latin typeface="Courier New"/>
-              <a:ea typeface="Courier New"/>
-              <a:cs typeface="Courier New"/>
-            </a:endParaRPr>
-          </a:p>
-        </p:txBody>
-      </p:sp>
-      <p:sp>
-        <p:nvSpPr>
           <p:cNvPr id="6" name="Rectangle 5">
             <a:extLst xmlns:a="http://schemas.openxmlformats.org/drawingml/2006/main">
               <a:ext uri="{FF2B5EF4-FFF2-40B4-BE49-F238E27FC236}">

</xml_diff>

<commit_message>
Source pptx: Forbes English logo on the cover and closing slides
</commit_message>
<xml_diff>
--- a/harry-potter-present-continuous.pptx
+++ b/harry-potter-present-continuous.pptx
@@ -2367,6 +2367,30 @@
           </a:p>
         </p:txBody>
       </p:sp>
+      <p:pic>
+        <p:nvPicPr>
+          <p:cNvPr id="900" name="Forbes English logo" descr="Forbes English"/>
+          <p:cNvPicPr>
+            <a:picLocks xmlns:a="http://schemas.openxmlformats.org/drawingml/2006/main" noChangeAspect="1"/>
+          </p:cNvPicPr>
+          <p:nvPr/>
+        </p:nvPicPr>
+        <p:blipFill>
+          <a:blip xmlns:a="http://schemas.openxmlformats.org/drawingml/2006/main" xmlns:r="http://schemas.openxmlformats.org/officeDocument/2006/relationships" r:embed="rIdFeLogo"/>
+          <a:stretch xmlns:a="http://schemas.openxmlformats.org/drawingml/2006/main">
+            <a:fillRect/>
+          </a:stretch>
+        </p:blipFill>
+        <p:spPr>
+          <a:xfrm xmlns:a="http://schemas.openxmlformats.org/drawingml/2006/main">
+            <a:off x="10757525" y="2790000"/>
+            <a:ext cx="999500" cy="520000"/>
+          </a:xfrm>
+          <a:prstGeom xmlns:a="http://schemas.openxmlformats.org/drawingml/2006/main" prst="rect">
+            <a:avLst/>
+          </a:prstGeom>
+        </p:spPr>
+      </p:pic>
     </p:spTree>
     <p:extLst>
       <p:ext uri="{BB962C8B-B14F-4D97-AF65-F5344CB8AC3E}">
@@ -3071,6 +3095,30 @@
           </a:p>
         </p:txBody>
       </p:sp>
+      <p:pic>
+        <p:nvPicPr>
+          <p:cNvPr id="900" name="Forbes English logo" descr="Forbes English"/>
+          <p:cNvPicPr>
+            <a:picLocks xmlns:a="http://schemas.openxmlformats.org/drawingml/2006/main" noChangeAspect="1"/>
+          </p:cNvPicPr>
+          <p:nvPr/>
+        </p:nvPicPr>
+        <p:blipFill>
+          <a:blip xmlns:a="http://schemas.openxmlformats.org/drawingml/2006/main" xmlns:r="http://schemas.openxmlformats.org/officeDocument/2006/relationships" r:embed="rIdFeLogo"/>
+          <a:stretch xmlns:a="http://schemas.openxmlformats.org/drawingml/2006/main">
+            <a:fillRect/>
+          </a:stretch>
+        </p:blipFill>
+        <p:spPr>
+          <a:xfrm xmlns:a="http://schemas.openxmlformats.org/drawingml/2006/main">
+            <a:off x="666750" y="5922000"/>
+            <a:ext cx="1300000" cy="676000"/>
+          </a:xfrm>
+          <a:prstGeom xmlns:a="http://schemas.openxmlformats.org/drawingml/2006/main" prst="rect">
+            <a:avLst/>
+          </a:prstGeom>
+        </p:spPr>
+      </p:pic>
     </p:spTree>
     <p:extLst>
       <p:ext uri="{BB962C8B-B14F-4D97-AF65-F5344CB8AC3E}">

</xml_diff>

<commit_message>
Source pptx: both logos in the bottom-right corner
</commit_message>
<xml_diff>
--- a/harry-potter-present-continuous.pptx
+++ b/harry-potter-present-continuous.pptx
@@ -2383,8 +2383,8 @@
         </p:blipFill>
         <p:spPr>
           <a:xfrm xmlns:a="http://schemas.openxmlformats.org/drawingml/2006/main">
-            <a:off x="10757525" y="2790000"/>
-            <a:ext cx="999500" cy="520000"/>
+            <a:off x="10502900" y="5600000"/>
+            <a:ext cx="1270000" cy="661000"/>
           </a:xfrm>
           <a:prstGeom xmlns:a="http://schemas.openxmlformats.org/drawingml/2006/main" prst="rect">
             <a:avLst/>
@@ -3111,8 +3111,8 @@
         </p:blipFill>
         <p:spPr>
           <a:xfrm xmlns:a="http://schemas.openxmlformats.org/drawingml/2006/main">
-            <a:off x="666750" y="5922000"/>
-            <a:ext cx="1300000" cy="676000"/>
+            <a:off x="10502900" y="5600000"/>
+            <a:ext cx="1270000" cy="661000"/>
           </a:xfrm>
           <a:prstGeom xmlns:a="http://schemas.openxmlformats.org/drawingml/2006/main" prst="rect">
             <a:avLst/>

</xml_diff>